<commit_message>
S3: the telling order belongs to the leaders (John's call on the v2.11 sibling flag) — standalone S3 pairs no longer fix Companion-first; arranged beforehand, with Companion-first kept as a depth-setting lever in the notes; small-room cue follows; combined form's cue gains the lever note; changelog v2.14
Co-Authored-By: Claude Fable 5 <noreply@anthropic.com>
</commit_message>
<xml_diff>
--- a/_implementation-notes/evening-series/FotH Evening Session 3 Slides DRAFT v1.pptx
+++ b/_implementation-notes/evening-series/FotH Evening Session 3 Slides DRAFT v1.pptx
@@ -1467,7 +1467,7 @@
           <a:p>
             <a:r>
               <a:rPr lang="en-US" sz="1200"/>
-              <a:t>CUES: Teen storytelling cards (H3.2) go home today for Week 4. Ten or fewer — stay one circle; the arranged parent tells after the Companion.</a:t>
+              <a:t>CUES: Teen storytelling cards (H3.2) go home today for Week 4. Ten or fewer — stay one circle; the arranged telling order holds.</a:t>
             </a:r>
           </a:p>
         </p:txBody>
@@ -1526,7 +1526,7 @@
           <a:p>
             <a:r>
               <a:rPr lang="en-US" sz="1200"/>
-              <a:t>1. In each pair: the Companion tells first, then the arranged parent, then the remaining parents. 5–7 minutes per story, 10 seconds of silence, 1–2 minute blessing round.</a:t>
+              <a:t>1. In each pair: the telling order is arranged beforehand — Companion-first stays available as a depth-setting lever when a pair needs it. 5–7 minutes per story, 10 seconds of silence, 1–2 minute blessing round.</a:t>
             </a:r>
           </a:p>
           <a:p>
@@ -5190,7 +5190,7 @@
                 </a:solidFill>
                 <a:latin typeface="Calibri"/>
               </a:rPr>
-              <a:t>Tonight’s tellers: the parents — plus any Companion-in-Formation. The Lead Companion goes first</a:t>
+              <a:t>Tonight’s tellers: the parents — plus any Companion-in-Formation. The telling order is arranged beforehand</a:t>
             </a:r>
           </a:p>
           <a:p>

</xml_diff>